<commit_message>
publiceer met kaartje op homepage en responsive
</commit_message>
<xml_diff>
--- a/input/schets-kaart.pptx
+++ b/input/schets-kaart.pptx
@@ -6,6 +6,7 @@
   </p:sldMasterIdLst>
   <p:sldIdLst>
     <p:sldId id="256" r:id="rId2"/>
+    <p:sldId id="257" r:id="rId3"/>
   </p:sldIdLst>
   <p:sldSz cx="12192000" cy="6858000"/>
   <p:notesSz cx="6858000" cy="9144000"/>
@@ -3347,12 +3348,42 @@
           <a:chExt cx="0" cy="0"/>
         </a:xfrm>
       </p:grpSpPr>
-      <p:sp>
-        <p:nvSpPr>
-          <p:cNvPr id="21" name="Rectangle 20">
-            <a:extLst>
-              <a:ext uri="{FF2B5EF4-FFF2-40B4-BE49-F238E27FC236}">
-                <a16:creationId xmlns:a16="http://schemas.microsoft.com/office/drawing/2014/main" id="{7386675E-3838-72F6-81EE-A729FA358ABD}"/>
+      <p:pic>
+        <p:nvPicPr>
+          <p:cNvPr id="37" name="Picture 36">
+            <a:extLst>
+              <a:ext uri="{FF2B5EF4-FFF2-40B4-BE49-F238E27FC236}">
+                <a16:creationId xmlns:a16="http://schemas.microsoft.com/office/drawing/2014/main" id="{212FBE15-7332-A3B3-9664-6D5E64E5DACE}"/>
+              </a:ext>
+            </a:extLst>
+          </p:cNvPr>
+          <p:cNvPicPr>
+            <a:picLocks noChangeAspect="1"/>
+          </p:cNvPicPr>
+          <p:nvPr/>
+        </p:nvPicPr>
+        <p:blipFill>
+          <a:blip r:embed="rId2"/>
+          <a:stretch>
+            <a:fillRect/>
+          </a:stretch>
+        </p:blipFill>
+        <p:spPr>
+          <a:xfrm rot="19640035">
+            <a:off x="873317" y="600780"/>
+            <a:ext cx="1660642" cy="1668402"/>
+          </a:xfrm>
+          <a:prstGeom prst="rect">
+            <a:avLst/>
+          </a:prstGeom>
+        </p:spPr>
+      </p:pic>
+      <p:sp>
+        <p:nvSpPr>
+          <p:cNvPr id="20" name="Rectangle 19">
+            <a:extLst>
+              <a:ext uri="{FF2B5EF4-FFF2-40B4-BE49-F238E27FC236}">
+                <a16:creationId xmlns:a16="http://schemas.microsoft.com/office/drawing/2014/main" id="{A6F83131-18DA-5776-09E5-CAC3BCB45A75}"/>
               </a:ext>
             </a:extLst>
           </p:cNvPr>
@@ -3360,8 +3391,125 @@
           <p:nvPr/>
         </p:nvSpPr>
         <p:spPr>
-          <a:xfrm rot="17825111">
-            <a:off x="5719036" y="2553961"/>
+          <a:xfrm>
+            <a:off x="5560531" y="1875332"/>
+            <a:ext cx="1877953" cy="154502"/>
+          </a:xfrm>
+          <a:prstGeom prst="rect">
+            <a:avLst/>
+          </a:prstGeom>
+          <a:solidFill>
+            <a:schemeClr val="tx1">
+              <a:lumMod val="75000"/>
+              <a:lumOff val="25000"/>
+            </a:schemeClr>
+          </a:solidFill>
+          <a:ln>
+            <a:noFill/>
+          </a:ln>
+        </p:spPr>
+        <p:style>
+          <a:lnRef idx="2">
+            <a:schemeClr val="accent1">
+              <a:shade val="15000"/>
+            </a:schemeClr>
+          </a:lnRef>
+          <a:fillRef idx="1">
+            <a:schemeClr val="accent1"/>
+          </a:fillRef>
+          <a:effectRef idx="0">
+            <a:schemeClr val="accent1"/>
+          </a:effectRef>
+          <a:fontRef idx="minor">
+            <a:schemeClr val="lt1"/>
+          </a:fontRef>
+        </p:style>
+        <p:txBody>
+          <a:bodyPr rtlCol="0" anchor="ctr"/>
+          <a:lstStyle/>
+          <a:p>
+            <a:pPr algn="ctr"/>
+            <a:r>
+              <a:rPr lang="nl-NL" sz="1100" dirty="0"/>
+              <a:t>muurtje</a:t>
+            </a:r>
+          </a:p>
+        </p:txBody>
+      </p:sp>
+      <p:sp>
+        <p:nvSpPr>
+          <p:cNvPr id="7" name="Rectangle 6">
+            <a:extLst>
+              <a:ext uri="{FF2B5EF4-FFF2-40B4-BE49-F238E27FC236}">
+                <a16:creationId xmlns:a16="http://schemas.microsoft.com/office/drawing/2014/main" id="{7608468F-86A5-CED7-6E3C-7A9E207C502A}"/>
+              </a:ext>
+            </a:extLst>
+          </p:cNvPr>
+          <p:cNvSpPr/>
+          <p:nvPr/>
+        </p:nvSpPr>
+        <p:spPr>
+          <a:xfrm rot="16196372">
+            <a:off x="3675467" y="4809823"/>
+            <a:ext cx="717483" cy="283571"/>
+          </a:xfrm>
+          <a:prstGeom prst="rect">
+            <a:avLst/>
+          </a:prstGeom>
+          <a:solidFill>
+            <a:schemeClr val="bg1"/>
+          </a:solidFill>
+          <a:ln>
+            <a:noFill/>
+          </a:ln>
+        </p:spPr>
+        <p:style>
+          <a:lnRef idx="2">
+            <a:schemeClr val="accent1">
+              <a:shade val="15000"/>
+            </a:schemeClr>
+          </a:lnRef>
+          <a:fillRef idx="1">
+            <a:schemeClr val="accent1"/>
+          </a:fillRef>
+          <a:effectRef idx="0">
+            <a:schemeClr val="accent1"/>
+          </a:effectRef>
+          <a:fontRef idx="minor">
+            <a:schemeClr val="lt1"/>
+          </a:fontRef>
+        </p:style>
+        <p:txBody>
+          <a:bodyPr rtlCol="0" anchor="ctr"/>
+          <a:lstStyle/>
+          <a:p>
+            <a:pPr algn="ctr"/>
+            <a:r>
+              <a:rPr lang="nl-NL" sz="600" dirty="0">
+                <a:solidFill>
+                  <a:schemeClr val="tx1"/>
+                </a:solidFill>
+              </a:rPr>
+              <a:t>parkeerplaats (grind)</a:t>
+            </a:r>
+          </a:p>
+        </p:txBody>
+      </p:sp>
+      <p:sp>
+        <p:nvSpPr>
+          <p:cNvPr id="21" name="Rectangle 20">
+            <a:extLst>
+              <a:ext uri="{FF2B5EF4-FFF2-40B4-BE49-F238E27FC236}">
+                <a16:creationId xmlns:a16="http://schemas.microsoft.com/office/drawing/2014/main" id="{7386675E-3838-72F6-81EE-A729FA358ABD}"/>
+              </a:ext>
+            </a:extLst>
+          </p:cNvPr>
+          <p:cNvSpPr/>
+          <p:nvPr/>
+        </p:nvSpPr>
+        <p:spPr>
+          <a:xfrm rot="16026713">
+            <a:off x="5435560" y="2146857"/>
             <a:ext cx="627298" cy="544473"/>
           </a:xfrm>
           <a:prstGeom prst="rect">
@@ -3412,8 +3560,8 @@
           <p:nvPr/>
         </p:nvSpPr>
         <p:spPr>
-          <a:xfrm rot="17789850">
-            <a:off x="4555148" y="1884677"/>
+          <a:xfrm rot="16200000">
+            <a:off x="4280190" y="1990494"/>
             <a:ext cx="1030521" cy="1401942"/>
           </a:xfrm>
           <a:prstGeom prst="rect">
@@ -3471,9 +3619,9 @@
           <p:nvPr/>
         </p:nvSpPr>
         <p:spPr>
-          <a:xfrm rot="7011101">
-            <a:off x="6674886" y="2119815"/>
-            <a:ext cx="320303" cy="1522955"/>
+          <a:xfrm rot="5400000">
+            <a:off x="6154752" y="1218050"/>
+            <a:ext cx="237823" cy="1877954"/>
           </a:xfrm>
           <a:prstGeom prst="rect">
             <a:avLst/>
@@ -3522,36 +3670,6 @@
           </a:p>
         </p:txBody>
       </p:sp>
-      <p:pic>
-        <p:nvPicPr>
-          <p:cNvPr id="5" name="Picture 4">
-            <a:extLst>
-              <a:ext uri="{FF2B5EF4-FFF2-40B4-BE49-F238E27FC236}">
-                <a16:creationId xmlns:a16="http://schemas.microsoft.com/office/drawing/2014/main" id="{9F834400-5AA1-52BC-51A7-C62468D46100}"/>
-              </a:ext>
-            </a:extLst>
-          </p:cNvPr>
-          <p:cNvPicPr>
-            <a:picLocks noChangeAspect="1"/>
-          </p:cNvPicPr>
-          <p:nvPr/>
-        </p:nvPicPr>
-        <p:blipFill>
-          <a:blip r:embed="rId2"/>
-          <a:stretch>
-            <a:fillRect/>
-          </a:stretch>
-        </p:blipFill>
-        <p:spPr>
-          <a:xfrm>
-            <a:off x="2083130" y="159503"/>
-            <a:ext cx="1114581" cy="1019317"/>
-          </a:xfrm>
-          <a:prstGeom prst="rect">
-            <a:avLst/>
-          </a:prstGeom>
-        </p:spPr>
-      </p:pic>
       <p:sp>
         <p:nvSpPr>
           <p:cNvPr id="6" name="Rectangle 5">
@@ -3565,9 +3683,9 @@
           <p:nvPr/>
         </p:nvSpPr>
         <p:spPr>
-          <a:xfrm rot="17846704">
-            <a:off x="3952342" y="3162437"/>
-            <a:ext cx="1062231" cy="1332747"/>
+          <a:xfrm rot="16200000">
+            <a:off x="4324554" y="3342819"/>
+            <a:ext cx="1062231" cy="1437567"/>
           </a:xfrm>
           <a:prstGeom prst="rect">
             <a:avLst/>
@@ -3627,8 +3745,8 @@
           <p:nvPr/>
         </p:nvSpPr>
         <p:spPr>
-          <a:xfrm rot="17955549">
-            <a:off x="4739880" y="3656436"/>
+          <a:xfrm rot="16157151">
+            <a:off x="5142859" y="3307475"/>
             <a:ext cx="1681960" cy="845658"/>
           </a:xfrm>
           <a:prstGeom prst="rect">
@@ -3689,9 +3807,9 @@
           <p:nvPr/>
         </p:nvSpPr>
         <p:spPr>
-          <a:xfrm rot="17702385">
-            <a:off x="7215527" y="3342835"/>
-            <a:ext cx="1348524" cy="1262983"/>
+          <a:xfrm rot="16200000">
+            <a:off x="7246220" y="1924833"/>
+            <a:ext cx="1362479" cy="1262983"/>
           </a:xfrm>
           <a:prstGeom prst="rect">
             <a:avLst/>
@@ -3751,9 +3869,9 @@
           <p:nvPr/>
         </p:nvSpPr>
         <p:spPr>
-          <a:xfrm rot="17955549">
-            <a:off x="4673575" y="3360810"/>
-            <a:ext cx="647557" cy="3429137"/>
+          <a:xfrm rot="16200000">
+            <a:off x="5589962" y="3107858"/>
+            <a:ext cx="647557" cy="3553709"/>
           </a:xfrm>
           <a:prstGeom prst="rect">
             <a:avLst/>
@@ -3791,7 +3909,7 @@
             <a:pPr algn="ctr"/>
             <a:r>
               <a:rPr lang="nl-NL" sz="1050" dirty="0"/>
-              <a:t>Buren</a:t>
+              <a:t>buren</a:t>
             </a:r>
           </a:p>
         </p:txBody>
@@ -3809,8 +3927,8 @@
           <p:nvPr/>
         </p:nvSpPr>
         <p:spPr>
-          <a:xfrm rot="17702385">
-            <a:off x="5100540" y="659986"/>
+          <a:xfrm rot="16200000">
+            <a:off x="4194012" y="562419"/>
             <a:ext cx="1308835" cy="1630819"/>
           </a:xfrm>
           <a:prstGeom prst="rect">
@@ -3867,9 +3985,9 @@
           <p:nvPr/>
         </p:nvSpPr>
         <p:spPr>
-          <a:xfrm rot="17955549">
-            <a:off x="7173760" y="5415397"/>
-            <a:ext cx="1486197" cy="215626"/>
+          <a:xfrm rot="16157151">
+            <a:off x="7986578" y="3818063"/>
+            <a:ext cx="1316694" cy="159480"/>
           </a:xfrm>
           <a:prstGeom prst="rect">
             <a:avLst/>
@@ -3906,7 +4024,7 @@
           <a:p>
             <a:pPr algn="ctr"/>
             <a:r>
-              <a:rPr lang="nl-NL" sz="1100" dirty="0"/>
+              <a:rPr lang="nl-NL" sz="1000" dirty="0"/>
               <a:t>muurtje</a:t>
             </a:r>
           </a:p>
@@ -3925,9 +4043,9 @@
           <p:nvPr/>
         </p:nvSpPr>
         <p:spPr>
-          <a:xfrm rot="17955549">
-            <a:off x="6903486" y="5484057"/>
-            <a:ext cx="629590" cy="1660837"/>
+          <a:xfrm rot="16200000">
+            <a:off x="8196186" y="4054292"/>
+            <a:ext cx="647557" cy="1660837"/>
           </a:xfrm>
           <a:prstGeom prst="rect">
             <a:avLst/>
@@ -3972,10 +4090,10 @@
       </p:sp>
       <p:sp>
         <p:nvSpPr>
-          <p:cNvPr id="20" name="Rectangle 19">
-            <a:extLst>
-              <a:ext uri="{FF2B5EF4-FFF2-40B4-BE49-F238E27FC236}">
-                <a16:creationId xmlns:a16="http://schemas.microsoft.com/office/drawing/2014/main" id="{A6F83131-18DA-5776-09E5-CAC3BCB45A75}"/>
+          <p:cNvPr id="22" name="Rectangle 21">
+            <a:extLst>
+              <a:ext uri="{FF2B5EF4-FFF2-40B4-BE49-F238E27FC236}">
+                <a16:creationId xmlns:a16="http://schemas.microsoft.com/office/drawing/2014/main" id="{B93EF2BC-7AC5-7CF8-03C3-6DE8148BC523}"/>
               </a:ext>
             </a:extLst>
           </p:cNvPr>
@@ -3983,67 +4101,9 @@
           <p:nvPr/>
         </p:nvSpPr>
         <p:spPr>
-          <a:xfrm rot="1585831">
-            <a:off x="6014483" y="2565137"/>
-            <a:ext cx="1686136" cy="154502"/>
-          </a:xfrm>
-          <a:prstGeom prst="rect">
-            <a:avLst/>
-          </a:prstGeom>
-          <a:solidFill>
-            <a:schemeClr val="tx1">
-              <a:lumMod val="75000"/>
-              <a:lumOff val="25000"/>
-            </a:schemeClr>
-          </a:solidFill>
-          <a:ln>
-            <a:noFill/>
-          </a:ln>
-        </p:spPr>
-        <p:style>
-          <a:lnRef idx="2">
-            <a:schemeClr val="accent1">
-              <a:shade val="15000"/>
-            </a:schemeClr>
-          </a:lnRef>
-          <a:fillRef idx="1">
-            <a:schemeClr val="accent1"/>
-          </a:fillRef>
-          <a:effectRef idx="0">
-            <a:schemeClr val="accent1"/>
-          </a:effectRef>
-          <a:fontRef idx="minor">
-            <a:schemeClr val="lt1"/>
-          </a:fontRef>
-        </p:style>
-        <p:txBody>
-          <a:bodyPr rtlCol="0" anchor="ctr"/>
-          <a:lstStyle/>
-          <a:p>
-            <a:pPr algn="ctr"/>
-            <a:r>
-              <a:rPr lang="nl-NL" sz="1100" dirty="0"/>
-              <a:t>muurtje</a:t>
-            </a:r>
-          </a:p>
-        </p:txBody>
-      </p:sp>
-      <p:sp>
-        <p:nvSpPr>
-          <p:cNvPr id="22" name="Rectangle 21">
-            <a:extLst>
-              <a:ext uri="{FF2B5EF4-FFF2-40B4-BE49-F238E27FC236}">
-                <a16:creationId xmlns:a16="http://schemas.microsoft.com/office/drawing/2014/main" id="{B93EF2BC-7AC5-7CF8-03C3-6DE8148BC523}"/>
-              </a:ext>
-            </a:extLst>
-          </p:cNvPr>
-          <p:cNvSpPr/>
-          <p:nvPr/>
-        </p:nvSpPr>
-        <p:spPr>
-          <a:xfrm rot="17789850">
-            <a:off x="6742185" y="1391709"/>
-            <a:ext cx="1030521" cy="1401942"/>
+          <a:xfrm rot="16200000">
+            <a:off x="5807567" y="1017617"/>
+            <a:ext cx="627991" cy="810829"/>
           </a:xfrm>
           <a:prstGeom prst="rect">
             <a:avLst/>
@@ -4100,9 +4160,9 @@
           <p:nvPr/>
         </p:nvSpPr>
         <p:spPr>
-          <a:xfrm rot="17789850">
-            <a:off x="7212987" y="4685338"/>
-            <a:ext cx="3003534" cy="646509"/>
+          <a:xfrm rot="16200000">
+            <a:off x="8421151" y="3682455"/>
+            <a:ext cx="1181999" cy="558571"/>
           </a:xfrm>
           <a:prstGeom prst="rect">
             <a:avLst/>
@@ -4159,9 +4219,9 @@
           <p:nvPr/>
         </p:nvSpPr>
         <p:spPr>
-          <a:xfrm rot="1633426">
-            <a:off x="3674498" y="2632593"/>
-            <a:ext cx="320303" cy="1349941"/>
+          <a:xfrm>
+            <a:off x="3895808" y="3370742"/>
+            <a:ext cx="241078" cy="1249657"/>
           </a:xfrm>
           <a:prstGeom prst="rect">
             <a:avLst/>
@@ -4223,9 +4283,9 @@
           <p:nvPr/>
         </p:nvSpPr>
         <p:spPr>
-          <a:xfrm rot="6971953">
-            <a:off x="4456448" y="2673881"/>
-            <a:ext cx="320303" cy="936104"/>
+          <a:xfrm rot="5400000">
+            <a:off x="4475560" y="2917181"/>
+            <a:ext cx="287408" cy="936104"/>
           </a:xfrm>
           <a:prstGeom prst="rect">
             <a:avLst/>
@@ -4287,9 +4347,9 @@
           <p:nvPr/>
         </p:nvSpPr>
         <p:spPr>
-          <a:xfrm rot="1736715">
-            <a:off x="7510924" y="4949696"/>
-            <a:ext cx="320303" cy="986422"/>
+          <a:xfrm>
+            <a:off x="8245234" y="3370742"/>
+            <a:ext cx="320303" cy="998752"/>
           </a:xfrm>
           <a:prstGeom prst="rect">
             <a:avLst/>
@@ -4351,9 +4411,9 @@
           <p:nvPr/>
         </p:nvSpPr>
         <p:spPr>
-          <a:xfrm rot="6987304">
-            <a:off x="7389096" y="4066597"/>
-            <a:ext cx="320303" cy="1284353"/>
+          <a:xfrm rot="5400000">
+            <a:off x="7809539" y="2691107"/>
+            <a:ext cx="191437" cy="1284353"/>
           </a:xfrm>
           <a:prstGeom prst="rect">
             <a:avLst/>
@@ -4415,9 +4475,9 @@
           <p:nvPr/>
         </p:nvSpPr>
         <p:spPr>
-          <a:xfrm rot="7220852">
-            <a:off x="5728193" y="4690321"/>
-            <a:ext cx="320303" cy="668358"/>
+          <a:xfrm rot="5422454">
+            <a:off x="6531024" y="4099908"/>
+            <a:ext cx="320303" cy="590783"/>
           </a:xfrm>
           <a:prstGeom prst="rect">
             <a:avLst/>
@@ -4479,8 +4539,8 @@
           <p:nvPr/>
         </p:nvSpPr>
         <p:spPr>
-          <a:xfrm rot="7220852">
-            <a:off x="6218112" y="4973737"/>
+          <a:xfrm rot="5422454">
+            <a:off x="7040039" y="4020951"/>
             <a:ext cx="487215" cy="588908"/>
           </a:xfrm>
           <a:prstGeom prst="rect">
@@ -4543,9 +4603,9 @@
           <p:nvPr/>
         </p:nvSpPr>
         <p:spPr>
-          <a:xfrm rot="7220852">
-            <a:off x="5890549" y="2780320"/>
-            <a:ext cx="312801" cy="855579"/>
+          <a:xfrm rot="5422454">
+            <a:off x="5854304" y="2360723"/>
+            <a:ext cx="235139" cy="855579"/>
           </a:xfrm>
           <a:prstGeom prst="rect">
             <a:avLst/>
@@ -4607,8 +4667,8 @@
           <p:nvPr/>
         </p:nvSpPr>
         <p:spPr>
-          <a:xfrm rot="1803632">
-            <a:off x="3592211" y="1264811"/>
+          <a:xfrm rot="5234">
+            <a:off x="3133798" y="2117919"/>
             <a:ext cx="348324" cy="1209079"/>
           </a:xfrm>
           <a:prstGeom prst="rect">
@@ -4671,8 +4731,8 @@
           <p:nvPr/>
         </p:nvSpPr>
         <p:spPr>
-          <a:xfrm rot="17902004">
-            <a:off x="1686877" y="2008399"/>
+          <a:xfrm rot="16200000">
+            <a:off x="1396074" y="2722121"/>
             <a:ext cx="4512062" cy="487403"/>
           </a:xfrm>
           <a:prstGeom prst="rect">
@@ -4719,10 +4779,10 @@
       </p:sp>
       <p:sp>
         <p:nvSpPr>
-          <p:cNvPr id="7" name="Rectangle 6">
-            <a:extLst>
-              <a:ext uri="{FF2B5EF4-FFF2-40B4-BE49-F238E27FC236}">
-                <a16:creationId xmlns:a16="http://schemas.microsoft.com/office/drawing/2014/main" id="{7608468F-86A5-CED7-6E3C-7A9E207C502A}"/>
+          <p:cNvPr id="8" name="Rectangle 7">
+            <a:extLst>
+              <a:ext uri="{FF2B5EF4-FFF2-40B4-BE49-F238E27FC236}">
+                <a16:creationId xmlns:a16="http://schemas.microsoft.com/office/drawing/2014/main" id="{F379DEC9-2DFE-9DE3-D542-9D708483B63F}"/>
               </a:ext>
             </a:extLst>
           </p:cNvPr>
@@ -4730,67 +4790,8 @@
           <p:nvPr/>
         </p:nvSpPr>
         <p:spPr>
-          <a:xfrm rot="17994770">
-            <a:off x="2969400" y="4057024"/>
-            <a:ext cx="717483" cy="283571"/>
-          </a:xfrm>
-          <a:prstGeom prst="rect">
-            <a:avLst/>
-          </a:prstGeom>
-          <a:solidFill>
-            <a:schemeClr val="bg1"/>
-          </a:solidFill>
-          <a:ln>
-            <a:noFill/>
-          </a:ln>
-        </p:spPr>
-        <p:style>
-          <a:lnRef idx="2">
-            <a:schemeClr val="accent1">
-              <a:shade val="15000"/>
-            </a:schemeClr>
-          </a:lnRef>
-          <a:fillRef idx="1">
-            <a:schemeClr val="accent1"/>
-          </a:fillRef>
-          <a:effectRef idx="0">
-            <a:schemeClr val="accent1"/>
-          </a:effectRef>
-          <a:fontRef idx="minor">
-            <a:schemeClr val="lt1"/>
-          </a:fontRef>
-        </p:style>
-        <p:txBody>
-          <a:bodyPr rtlCol="0" anchor="ctr"/>
-          <a:lstStyle/>
-          <a:p>
-            <a:pPr algn="ctr"/>
-            <a:r>
-              <a:rPr lang="nl-NL" sz="600" dirty="0">
-                <a:solidFill>
-                  <a:schemeClr val="tx1"/>
-                </a:solidFill>
-              </a:rPr>
-              <a:t>parkeerplaats (grind)</a:t>
-            </a:r>
-          </a:p>
-        </p:txBody>
-      </p:sp>
-      <p:sp>
-        <p:nvSpPr>
-          <p:cNvPr id="8" name="Rectangle 7">
-            <a:extLst>
-              <a:ext uri="{FF2B5EF4-FFF2-40B4-BE49-F238E27FC236}">
-                <a16:creationId xmlns:a16="http://schemas.microsoft.com/office/drawing/2014/main" id="{F379DEC9-2DFE-9DE3-D542-9D708483B63F}"/>
-              </a:ext>
-            </a:extLst>
-          </p:cNvPr>
-          <p:cNvSpPr/>
-          <p:nvPr/>
-        </p:nvSpPr>
-        <p:spPr>
-          <a:xfrm rot="1803632">
-            <a:off x="2841825" y="2233721"/>
+          <a:xfrm rot="5234">
+            <a:off x="3154482" y="3289671"/>
             <a:ext cx="320303" cy="1948775"/>
           </a:xfrm>
           <a:prstGeom prst="rect">
@@ -4853,8 +4854,8 @@
           <p:nvPr/>
         </p:nvSpPr>
         <p:spPr>
-          <a:xfrm rot="1803632">
-            <a:off x="4264071" y="20048"/>
+          <a:xfrm rot="5234">
+            <a:off x="3159635" y="711442"/>
             <a:ext cx="254713" cy="1447081"/>
           </a:xfrm>
           <a:prstGeom prst="rect">
@@ -4917,9 +4918,9 @@
           <p:nvPr/>
         </p:nvSpPr>
         <p:spPr>
-          <a:xfrm rot="1803632">
-            <a:off x="3215233" y="-325045"/>
-            <a:ext cx="320303" cy="4505743"/>
+          <a:xfrm rot="5234">
+            <a:off x="2678250" y="715456"/>
+            <a:ext cx="480380" cy="4505743"/>
           </a:xfrm>
           <a:prstGeom prst="rect">
             <a:avLst/>
@@ -4981,9 +4982,9 @@
           <p:nvPr/>
         </p:nvSpPr>
         <p:spPr>
-          <a:xfrm rot="17789850">
-            <a:off x="4321294" y="941586"/>
-            <a:ext cx="1398794" cy="279254"/>
+          <a:xfrm rot="16200000">
+            <a:off x="3320463" y="1292536"/>
+            <a:ext cx="1398794" cy="241078"/>
           </a:xfrm>
           <a:prstGeom prst="rect">
             <a:avLst/>
@@ -4992,11 +4993,7 @@
             <a:schemeClr val="bg1"/>
           </a:solidFill>
           <a:ln>
-            <a:solidFill>
-              <a:schemeClr val="accent1">
-                <a:shade val="15000"/>
-              </a:schemeClr>
-            </a:solidFill>
+            <a:noFill/>
           </a:ln>
         </p:spPr>
         <p:style>
@@ -5044,9 +5041,9 @@
           <p:nvPr/>
         </p:nvSpPr>
         <p:spPr>
-          <a:xfrm rot="1590481">
-            <a:off x="6897673" y="3243946"/>
-            <a:ext cx="320303" cy="1317961"/>
+          <a:xfrm>
+            <a:off x="7011730" y="2029587"/>
+            <a:ext cx="277003" cy="1399413"/>
           </a:xfrm>
           <a:prstGeom prst="rect">
             <a:avLst/>
@@ -5095,10 +5092,159 @@
           </a:p>
         </p:txBody>
       </p:sp>
+      <p:sp>
+        <p:nvSpPr>
+          <p:cNvPr id="35" name="Rectangle 34">
+            <a:extLst>
+              <a:ext uri="{FF2B5EF4-FFF2-40B4-BE49-F238E27FC236}">
+                <a16:creationId xmlns:a16="http://schemas.microsoft.com/office/drawing/2014/main" id="{B902EE83-62E2-B8EC-5145-5C845354778F}"/>
+              </a:ext>
+            </a:extLst>
+          </p:cNvPr>
+          <p:cNvSpPr/>
+          <p:nvPr/>
+        </p:nvSpPr>
+        <p:spPr>
+          <a:xfrm rot="16200000">
+            <a:off x="8434662" y="2240046"/>
+            <a:ext cx="1181999" cy="646509"/>
+          </a:xfrm>
+          <a:prstGeom prst="rect">
+            <a:avLst/>
+          </a:prstGeom>
+          <a:solidFill>
+            <a:schemeClr val="bg1"/>
+          </a:solidFill>
+          <a:ln>
+            <a:noFill/>
+          </a:ln>
+        </p:spPr>
+        <p:style>
+          <a:lnRef idx="2">
+            <a:schemeClr val="accent1">
+              <a:shade val="15000"/>
+            </a:schemeClr>
+          </a:lnRef>
+          <a:fillRef idx="1">
+            <a:schemeClr val="accent1"/>
+          </a:fillRef>
+          <a:effectRef idx="0">
+            <a:schemeClr val="accent1"/>
+          </a:effectRef>
+          <a:fontRef idx="minor">
+            <a:schemeClr val="lt1"/>
+          </a:fontRef>
+        </p:style>
+        <p:txBody>
+          <a:bodyPr rtlCol="0" anchor="ctr"/>
+          <a:lstStyle/>
+          <a:p>
+            <a:pPr algn="ctr"/>
+            <a:r>
+              <a:rPr lang="nl-NL" sz="1050" dirty="0">
+                <a:solidFill>
+                  <a:schemeClr val="tx1"/>
+                </a:solidFill>
+              </a:rPr>
+              <a:t>tuin buren</a:t>
+            </a:r>
+          </a:p>
+        </p:txBody>
+      </p:sp>
+      <p:pic>
+        <p:nvPicPr>
+          <p:cNvPr id="39" name="Picture 38">
+            <a:extLst>
+              <a:ext uri="{FF2B5EF4-FFF2-40B4-BE49-F238E27FC236}">
+                <a16:creationId xmlns:a16="http://schemas.microsoft.com/office/drawing/2014/main" id="{98794A84-501E-0E92-A566-9EEF7E96C93C}"/>
+              </a:ext>
+            </a:extLst>
+          </p:cNvPr>
+          <p:cNvPicPr>
+            <a:picLocks noChangeAspect="1"/>
+          </p:cNvPicPr>
+          <p:nvPr/>
+        </p:nvPicPr>
+        <p:blipFill>
+          <a:blip r:embed="rId3"/>
+          <a:stretch>
+            <a:fillRect/>
+          </a:stretch>
+        </p:blipFill>
+        <p:spPr>
+          <a:xfrm>
+            <a:off x="9515452" y="534803"/>
+            <a:ext cx="2033871" cy="4775697"/>
+          </a:xfrm>
+          <a:prstGeom prst="rect">
+            <a:avLst/>
+          </a:prstGeom>
+        </p:spPr>
+      </p:pic>
     </p:spTree>
     <p:extLst>
       <p:ext uri="{BB962C8B-B14F-4D97-AF65-F5344CB8AC3E}">
         <p14:creationId xmlns:p14="http://schemas.microsoft.com/office/powerpoint/2010/main" val="2968107597"/>
+      </p:ext>
+    </p:extLst>
+  </p:cSld>
+  <p:clrMapOvr>
+    <a:masterClrMapping/>
+  </p:clrMapOvr>
+</p:sld>
+</file>
+
+<file path=ppt/slides/slide2.xml><?xml version="1.0" encoding="utf-8"?>
+<p:sld xmlns:a="http://schemas.openxmlformats.org/drawingml/2006/main" xmlns:r="http://schemas.openxmlformats.org/officeDocument/2006/relationships" xmlns:p="http://schemas.openxmlformats.org/presentationml/2006/main">
+  <p:cSld>
+    <p:spTree>
+      <p:nvGrpSpPr>
+        <p:cNvPr id="1" name=""/>
+        <p:cNvGrpSpPr/>
+        <p:nvPr/>
+      </p:nvGrpSpPr>
+      <p:grpSpPr>
+        <a:xfrm>
+          <a:off x="0" y="0"/>
+          <a:ext cx="0" cy="0"/>
+          <a:chOff x="0" y="0"/>
+          <a:chExt cx="0" cy="0"/>
+        </a:xfrm>
+      </p:grpSpPr>
+      <p:pic>
+        <p:nvPicPr>
+          <p:cNvPr id="102" name="Picture 101">
+            <a:extLst>
+              <a:ext uri="{FF2B5EF4-FFF2-40B4-BE49-F238E27FC236}">
+                <a16:creationId xmlns:a16="http://schemas.microsoft.com/office/drawing/2014/main" id="{78C2C5C8-482A-C46A-7D9A-79C430153F31}"/>
+              </a:ext>
+            </a:extLst>
+          </p:cNvPr>
+          <p:cNvPicPr>
+            <a:picLocks noChangeAspect="1"/>
+          </p:cNvPicPr>
+          <p:nvPr/>
+        </p:nvPicPr>
+        <p:blipFill>
+          <a:blip r:embed="rId2"/>
+          <a:stretch>
+            <a:fillRect/>
+          </a:stretch>
+        </p:blipFill>
+        <p:spPr>
+          <a:xfrm>
+            <a:off x="0" y="511083"/>
+            <a:ext cx="12058627" cy="5518241"/>
+          </a:xfrm>
+          <a:prstGeom prst="rect">
+            <a:avLst/>
+          </a:prstGeom>
+        </p:spPr>
+      </p:pic>
+    </p:spTree>
+    <p:extLst>
+      <p:ext uri="{BB962C8B-B14F-4D97-AF65-F5344CB8AC3E}">
+        <p14:creationId xmlns:p14="http://schemas.microsoft.com/office/powerpoint/2010/main" val="386756818"/>
       </p:ext>
     </p:extLst>
   </p:cSld>

</xml_diff>